<commit_message>
docs: fix presentation slides 8 and 20 layout overflow
- Slide 8 (architecture): boxes were extending past slide width;
  reorganized layout, added connectors/arrows for visual flow
- Slide 20 (testing): 13 rows didn't fit in slide;
  consolidated into 7 functional areas + total row

Co-Authored-By: Claude Opus 4.7 <noreply@anthropic.com>
</commit_message>
<xml_diff>
--- a/presentacion_pay2peer.pptx
+++ b/presentacion_pay2peer.pptx
@@ -7152,7 +7152,7 @@
               </a:defRPr>
             </a:pPr>
             <a:r>
-              <a:t>Distribución de tests</a:t>
+              <a:t>Distribución de tests por área</a:t>
             </a:r>
           </a:p>
         </p:txBody>
@@ -7210,7 +7210,7 @@
         </p:nvGraphicFramePr>
         <p:xfrm>
           <a:off x="731520" y="1645920"/>
-          <a:ext cx="10515600" cy="7040880"/>
+          <a:ext cx="10515600" cy="4526280"/>
         </p:xfrm>
         <a:graphic>
           <a:graphicData uri="http://schemas.openxmlformats.org/drawingml/2006/table">
@@ -7238,7 +7238,7 @@
                         </a:defRPr>
                       </a:pPr>
                       <a:r>
-                        <a:t>Suite</a:t>
+                        <a:t>Área funcional</a:t>
                       </a:r>
                     </a:p>
                   </a:txBody>
@@ -7312,7 +7312,7 @@
                         </a:defRPr>
                       </a:pPr>
                       <a:r>
-                        <a:t>01-auth</a:t>
+                        <a:t>Autenticación</a:t>
                       </a:r>
                     </a:p>
                   </a:txBody>
@@ -7336,7 +7336,451 @@
                         </a:defRPr>
                       </a:pPr>
                       <a:r>
-                        <a:t>Registro, login, refresh, logout</a:t>
+                        <a:t>Login, refresh, logout, lifecycle de tokens, 2FA TOTP</a:t>
+                      </a:r>
+                    </a:p>
+                  </a:txBody>
+                  <a:tcPr>
+                    <a:solidFill>
+                      <a:srgbClr val="F8FAFC"/>
+                    </a:solidFill>
+                  </a:tcPr>
+                </a:tc>
+                <a:tc>
+                  <a:txBody>
+                    <a:bodyPr/>
+                    <a:lstStyle/>
+                    <a:p>
+                      <a:pPr>
+                        <a:defRPr sz="1400">
+                          <a:solidFill>
+                            <a:srgbClr val="1E293B"/>
+                          </a:solidFill>
+                          <a:latin typeface="Calibri"/>
+                        </a:defRPr>
+                      </a:pPr>
+                      <a:r>
+                        <a:t>32</a:t>
+                      </a:r>
+                    </a:p>
+                  </a:txBody>
+                  <a:tcPr>
+                    <a:solidFill>
+                      <a:srgbClr val="F8FAFC"/>
+                    </a:solidFill>
+                  </a:tcPr>
+                </a:tc>
+              </a:tr>
+              <a:tr h="502920">
+                <a:tc>
+                  <a:txBody>
+                    <a:bodyPr/>
+                    <a:lstStyle/>
+                    <a:p>
+                      <a:pPr>
+                        <a:defRPr sz="1400">
+                          <a:solidFill>
+                            <a:srgbClr val="1E293B"/>
+                          </a:solidFill>
+                          <a:latin typeface="Calibri"/>
+                        </a:defRPr>
+                      </a:pPr>
+                      <a:r>
+                        <a:t>Wallet &amp; Pagos</a:t>
+                      </a:r>
+                    </a:p>
+                  </a:txBody>
+                  <a:tcPr>
+                    <a:solidFill>
+                      <a:srgbClr val="FFFFFF"/>
+                    </a:solidFill>
+                  </a:tcPr>
+                </a:tc>
+                <a:tc>
+                  <a:txBody>
+                    <a:bodyPr/>
+                    <a:lstStyle/>
+                    <a:p>
+                      <a:pPr>
+                        <a:defRPr sz="1400">
+                          <a:solidFill>
+                            <a:srgbClr val="1E293B"/>
+                          </a:solidFill>
+                          <a:latin typeface="Calibri"/>
+                        </a:defRPr>
+                      </a:pPr>
+                      <a:r>
+                        <a:t>Balance, fondos, transferencias P2P, paginación</a:t>
+                      </a:r>
+                    </a:p>
+                  </a:txBody>
+                  <a:tcPr>
+                    <a:solidFill>
+                      <a:srgbClr val="FFFFFF"/>
+                    </a:solidFill>
+                  </a:tcPr>
+                </a:tc>
+                <a:tc>
+                  <a:txBody>
+                    <a:bodyPr/>
+                    <a:lstStyle/>
+                    <a:p>
+                      <a:pPr>
+                        <a:defRPr sz="1400">
+                          <a:solidFill>
+                            <a:srgbClr val="1E293B"/>
+                          </a:solidFill>
+                          <a:latin typeface="Calibri"/>
+                        </a:defRPr>
+                      </a:pPr>
+                      <a:r>
+                        <a:t>22</a:t>
+                      </a:r>
+                    </a:p>
+                  </a:txBody>
+                  <a:tcPr>
+                    <a:solidFill>
+                      <a:srgbClr val="FFFFFF"/>
+                    </a:solidFill>
+                  </a:tcPr>
+                </a:tc>
+              </a:tr>
+              <a:tr h="502920">
+                <a:tc>
+                  <a:txBody>
+                    <a:bodyPr/>
+                    <a:lstStyle/>
+                    <a:p>
+                      <a:pPr>
+                        <a:defRPr sz="1400">
+                          <a:solidFill>
+                            <a:srgbClr val="1E293B"/>
+                          </a:solidFill>
+                          <a:latin typeface="Calibri"/>
+                        </a:defRPr>
+                      </a:pPr>
+                      <a:r>
+                        <a:t>Seguridad</a:t>
+                      </a:r>
+                    </a:p>
+                  </a:txBody>
+                  <a:tcPr>
+                    <a:solidFill>
+                      <a:srgbClr val="F8FAFC"/>
+                    </a:solidFill>
+                  </a:tcPr>
+                </a:tc>
+                <a:tc>
+                  <a:txBody>
+                    <a:bodyPr/>
+                    <a:lstStyle/>
+                    <a:p>
+                      <a:pPr>
+                        <a:defRPr sz="1400">
+                          <a:solidFill>
+                            <a:srgbClr val="1E293B"/>
+                          </a:solidFill>
+                          <a:latin typeface="Calibri"/>
+                        </a:defRPr>
+                      </a:pPr>
+                      <a:r>
+                        <a:t>OWASP Top 10, rate limiting (4 niveles), RBAC</a:t>
+                      </a:r>
+                    </a:p>
+                  </a:txBody>
+                  <a:tcPr>
+                    <a:solidFill>
+                      <a:srgbClr val="F8FAFC"/>
+                    </a:solidFill>
+                  </a:tcPr>
+                </a:tc>
+                <a:tc>
+                  <a:txBody>
+                    <a:bodyPr/>
+                    <a:lstStyle/>
+                    <a:p>
+                      <a:pPr>
+                        <a:defRPr sz="1400">
+                          <a:solidFill>
+                            <a:srgbClr val="1E293B"/>
+                          </a:solidFill>
+                          <a:latin typeface="Calibri"/>
+                        </a:defRPr>
+                      </a:pPr>
+                      <a:r>
+                        <a:t>33</a:t>
+                      </a:r>
+                    </a:p>
+                  </a:txBody>
+                  <a:tcPr>
+                    <a:solidFill>
+                      <a:srgbClr val="F8FAFC"/>
+                    </a:solidFill>
+                  </a:tcPr>
+                </a:tc>
+              </a:tr>
+              <a:tr h="502920">
+                <a:tc>
+                  <a:txBody>
+                    <a:bodyPr/>
+                    <a:lstStyle/>
+                    <a:p>
+                      <a:pPr>
+                        <a:defRPr sz="1400">
+                          <a:solidFill>
+                            <a:srgbClr val="1E293B"/>
+                          </a:solidFill>
+                          <a:latin typeface="Calibri"/>
+                        </a:defRPr>
+                      </a:pPr>
+                      <a:r>
+                        <a:t>Stripe</a:t>
+                      </a:r>
+                    </a:p>
+                  </a:txBody>
+                  <a:tcPr>
+                    <a:solidFill>
+                      <a:srgbClr val="FFFFFF"/>
+                    </a:solidFill>
+                  </a:tcPr>
+                </a:tc>
+                <a:tc>
+                  <a:txBody>
+                    <a:bodyPr/>
+                    <a:lstStyle/>
+                    <a:p>
+                      <a:pPr>
+                        <a:defRPr sz="1400">
+                          <a:solidFill>
+                            <a:srgbClr val="1E293B"/>
+                          </a:solidFill>
+                          <a:latin typeface="Calibri"/>
+                        </a:defRPr>
+                      </a:pPr>
+                      <a:r>
+                        <a:t>Webhooks (firma), Stripe Connect, retiros, rollback</a:t>
+                      </a:r>
+                    </a:p>
+                  </a:txBody>
+                  <a:tcPr>
+                    <a:solidFill>
+                      <a:srgbClr val="FFFFFF"/>
+                    </a:solidFill>
+                  </a:tcPr>
+                </a:tc>
+                <a:tc>
+                  <a:txBody>
+                    <a:bodyPr/>
+                    <a:lstStyle/>
+                    <a:p>
+                      <a:pPr>
+                        <a:defRPr sz="1400">
+                          <a:solidFill>
+                            <a:srgbClr val="1E293B"/>
+                          </a:solidFill>
+                          <a:latin typeface="Calibri"/>
+                        </a:defRPr>
+                      </a:pPr>
+                      <a:r>
+                        <a:t>21</a:t>
+                      </a:r>
+                    </a:p>
+                  </a:txBody>
+                  <a:tcPr>
+                    <a:solidFill>
+                      <a:srgbClr val="FFFFFF"/>
+                    </a:solidFill>
+                  </a:tcPr>
+                </a:tc>
+              </a:tr>
+              <a:tr h="502920">
+                <a:tc>
+                  <a:txBody>
+                    <a:bodyPr/>
+                    <a:lstStyle/>
+                    <a:p>
+                      <a:pPr>
+                        <a:defRPr sz="1400">
+                          <a:solidFill>
+                            <a:srgbClr val="1E293B"/>
+                          </a:solidFill>
+                          <a:latin typeface="Calibri"/>
+                        </a:defRPr>
+                      </a:pPr>
+                      <a:r>
+                        <a:t>LOPD / GDPR</a:t>
+                      </a:r>
+                    </a:p>
+                  </a:txBody>
+                  <a:tcPr>
+                    <a:solidFill>
+                      <a:srgbClr val="F8FAFC"/>
+                    </a:solidFill>
+                  </a:tcPr>
+                </a:tc>
+                <a:tc>
+                  <a:txBody>
+                    <a:bodyPr/>
+                    <a:lstStyle/>
+                    <a:p>
+                      <a:pPr>
+                        <a:defRPr sz="1400">
+                          <a:solidFill>
+                            <a:srgbClr val="1E293B"/>
+                          </a:solidFill>
+                          <a:latin typeface="Calibri"/>
+                        </a:defRPr>
+                      </a:pPr>
+                      <a:r>
+                        <a:t>Consentimiento, derecho al olvido, exportación</a:t>
+                      </a:r>
+                    </a:p>
+                  </a:txBody>
+                  <a:tcPr>
+                    <a:solidFill>
+                      <a:srgbClr val="F8FAFC"/>
+                    </a:solidFill>
+                  </a:tcPr>
+                </a:tc>
+                <a:tc>
+                  <a:txBody>
+                    <a:bodyPr/>
+                    <a:lstStyle/>
+                    <a:p>
+                      <a:pPr>
+                        <a:defRPr sz="1400">
+                          <a:solidFill>
+                            <a:srgbClr val="1E293B"/>
+                          </a:solidFill>
+                          <a:latin typeface="Calibri"/>
+                        </a:defRPr>
+                      </a:pPr>
+                      <a:r>
+                        <a:t>12</a:t>
+                      </a:r>
+                    </a:p>
+                  </a:txBody>
+                  <a:tcPr>
+                    <a:solidFill>
+                      <a:srgbClr val="F8FAFC"/>
+                    </a:solidFill>
+                  </a:tcPr>
+                </a:tc>
+              </a:tr>
+              <a:tr h="502920">
+                <a:tc>
+                  <a:txBody>
+                    <a:bodyPr/>
+                    <a:lstStyle/>
+                    <a:p>
+                      <a:pPr>
+                        <a:defRPr sz="1400">
+                          <a:solidFill>
+                            <a:srgbClr val="1E293B"/>
+                          </a:solidFill>
+                          <a:latin typeface="Calibri"/>
+                        </a:defRPr>
+                      </a:pPr>
+                      <a:r>
+                        <a:t>Blockchain</a:t>
+                      </a:r>
+                    </a:p>
+                  </a:txBody>
+                  <a:tcPr>
+                    <a:solidFill>
+                      <a:srgbClr val="FFFFFF"/>
+                    </a:solidFill>
+                  </a:tcPr>
+                </a:tc>
+                <a:tc>
+                  <a:txBody>
+                    <a:bodyPr/>
+                    <a:lstStyle/>
+                    <a:p>
+                      <a:pPr>
+                        <a:defRPr sz="1400">
+                          <a:solidFill>
+                            <a:srgbClr val="1E293B"/>
+                          </a:solidFill>
+                          <a:latin typeface="Calibri"/>
+                        </a:defRPr>
+                      </a:pPr>
+                      <a:r>
+                        <a:t>Verificación de cadena, sellado, integridad</a:t>
+                      </a:r>
+                    </a:p>
+                  </a:txBody>
+                  <a:tcPr>
+                    <a:solidFill>
+                      <a:srgbClr val="FFFFFF"/>
+                    </a:solidFill>
+                  </a:tcPr>
+                </a:tc>
+                <a:tc>
+                  <a:txBody>
+                    <a:bodyPr/>
+                    <a:lstStyle/>
+                    <a:p>
+                      <a:pPr>
+                        <a:defRPr sz="1400">
+                          <a:solidFill>
+                            <a:srgbClr val="1E293B"/>
+                          </a:solidFill>
+                          <a:latin typeface="Calibri"/>
+                        </a:defRPr>
+                      </a:pPr>
+                      <a:r>
+                        <a:t>10</a:t>
+                      </a:r>
+                    </a:p>
+                  </a:txBody>
+                  <a:tcPr>
+                    <a:solidFill>
+                      <a:srgbClr val="FFFFFF"/>
+                    </a:solidFill>
+                  </a:tcPr>
+                </a:tc>
+              </a:tr>
+              <a:tr h="502920">
+                <a:tc>
+                  <a:txBody>
+                    <a:bodyPr/>
+                    <a:lstStyle/>
+                    <a:p>
+                      <a:pPr>
+                        <a:defRPr sz="1400">
+                          <a:solidFill>
+                            <a:srgbClr val="1E293B"/>
+                          </a:solidFill>
+                          <a:latin typeface="Calibri"/>
+                        </a:defRPr>
+                      </a:pPr>
+                      <a:r>
+                        <a:t>Funcionalidades</a:t>
+                      </a:r>
+                    </a:p>
+                  </a:txBody>
+                  <a:tcPr>
+                    <a:solidFill>
+                      <a:srgbClr val="F8FAFC"/>
+                    </a:solidFill>
+                  </a:tcPr>
+                </a:tc>
+                <a:tc>
+                  <a:txBody>
+                    <a:bodyPr/>
+                    <a:lstStyle/>
+                    <a:p>
+                      <a:pPr>
+                        <a:defRPr sz="1400">
+                          <a:solidFill>
+                            <a:srgbClr val="1E293B"/>
+                          </a:solidFill>
+                          <a:latin typeface="Calibri"/>
+                        </a:defRPr>
+                      </a:pPr>
+                      <a:r>
+                        <a:t>Solicitudes, retiros simulados, freeze de wallet</a:t>
                       </a:r>
                     </a:p>
                   </a:txBody>
@@ -7386,7 +7830,7 @@
                         </a:defRPr>
                       </a:pPr>
                       <a:r>
-                        <a:t>02-wallet</a:t>
+                        <a:t>TOTAL</a:t>
                       </a:r>
                     </a:p>
                   </a:txBody>
@@ -7410,7 +7854,7 @@
                         </a:defRPr>
                       </a:pPr>
                       <a:r>
-                        <a:t>Balance, fondos, operaciones</a:t>
+                        <a:t>13 suites · 100 % de éxito</a:t>
                       </a:r>
                     </a:p>
                   </a:txBody>
@@ -7434,827 +7878,13 @@
                         </a:defRPr>
                       </a:pPr>
                       <a:r>
-                        <a:t>10</a:t>
+                        <a:t>149</a:t>
                       </a:r>
                     </a:p>
                   </a:txBody>
                   <a:tcPr>
                     <a:solidFill>
                       <a:srgbClr val="FFFFFF"/>
-                    </a:solidFill>
-                  </a:tcPr>
-                </a:tc>
-              </a:tr>
-              <a:tr h="502920">
-                <a:tc>
-                  <a:txBody>
-                    <a:bodyPr/>
-                    <a:lstStyle/>
-                    <a:p>
-                      <a:pPr>
-                        <a:defRPr sz="1400">
-                          <a:solidFill>
-                            <a:srgbClr val="1E293B"/>
-                          </a:solidFill>
-                          <a:latin typeface="Calibri"/>
-                        </a:defRPr>
-                      </a:pPr>
-                      <a:r>
-                        <a:t>03-transactions</a:t>
-                      </a:r>
-                    </a:p>
-                  </a:txBody>
-                  <a:tcPr>
-                    <a:solidFill>
-                      <a:srgbClr val="F8FAFC"/>
-                    </a:solidFill>
-                  </a:tcPr>
-                </a:tc>
-                <a:tc>
-                  <a:txBody>
-                    <a:bodyPr/>
-                    <a:lstStyle/>
-                    <a:p>
-                      <a:pPr>
-                        <a:defRPr sz="1400">
-                          <a:solidFill>
-                            <a:srgbClr val="1E293B"/>
-                          </a:solidFill>
-                          <a:latin typeface="Calibri"/>
-                        </a:defRPr>
-                      </a:pPr>
-                      <a:r>
-                        <a:t>Transferencias P2P, paginación</a:t>
-                      </a:r>
-                    </a:p>
-                  </a:txBody>
-                  <a:tcPr>
-                    <a:solidFill>
-                      <a:srgbClr val="F8FAFC"/>
-                    </a:solidFill>
-                  </a:tcPr>
-                </a:tc>
-                <a:tc>
-                  <a:txBody>
-                    <a:bodyPr/>
-                    <a:lstStyle/>
-                    <a:p>
-                      <a:pPr>
-                        <a:defRPr sz="1400">
-                          <a:solidFill>
-                            <a:srgbClr val="1E293B"/>
-                          </a:solidFill>
-                          <a:latin typeface="Calibri"/>
-                        </a:defRPr>
-                      </a:pPr>
-                      <a:r>
-                        <a:t>12</a:t>
-                      </a:r>
-                    </a:p>
-                  </a:txBody>
-                  <a:tcPr>
-                    <a:solidFill>
-                      <a:srgbClr val="F8FAFC"/>
-                    </a:solidFill>
-                  </a:tcPr>
-                </a:tc>
-              </a:tr>
-              <a:tr h="502920">
-                <a:tc>
-                  <a:txBody>
-                    <a:bodyPr/>
-                    <a:lstStyle/>
-                    <a:p>
-                      <a:pPr>
-                        <a:defRPr sz="1400">
-                          <a:solidFill>
-                            <a:srgbClr val="1E293B"/>
-                          </a:solidFill>
-                          <a:latin typeface="Calibri"/>
-                        </a:defRPr>
-                      </a:pPr>
-                      <a:r>
-                        <a:t>04-token-lifecycle</a:t>
-                      </a:r>
-                    </a:p>
-                  </a:txBody>
-                  <a:tcPr>
-                    <a:solidFill>
-                      <a:srgbClr val="FFFFFF"/>
-                    </a:solidFill>
-                  </a:tcPr>
-                </a:tc>
-                <a:tc>
-                  <a:txBody>
-                    <a:bodyPr/>
-                    <a:lstStyle/>
-                    <a:p>
-                      <a:pPr>
-                        <a:defRPr sz="1400">
-                          <a:solidFill>
-                            <a:srgbClr val="1E293B"/>
-                          </a:solidFill>
-                          <a:latin typeface="Calibri"/>
-                        </a:defRPr>
-                      </a:pPr>
-                      <a:r>
-                        <a:t>Expiración, rotación, revocación</a:t>
-                      </a:r>
-                    </a:p>
-                  </a:txBody>
-                  <a:tcPr>
-                    <a:solidFill>
-                      <a:srgbClr val="FFFFFF"/>
-                    </a:solidFill>
-                  </a:tcPr>
-                </a:tc>
-                <a:tc>
-                  <a:txBody>
-                    <a:bodyPr/>
-                    <a:lstStyle/>
-                    <a:p>
-                      <a:pPr>
-                        <a:defRPr sz="1400">
-                          <a:solidFill>
-                            <a:srgbClr val="1E293B"/>
-                          </a:solidFill>
-                          <a:latin typeface="Calibri"/>
-                        </a:defRPr>
-                      </a:pPr>
-                      <a:r>
-                        <a:t>8</a:t>
-                      </a:r>
-                    </a:p>
-                  </a:txBody>
-                  <a:tcPr>
-                    <a:solidFill>
-                      <a:srgbClr val="FFFFFF"/>
-                    </a:solidFill>
-                  </a:tcPr>
-                </a:tc>
-              </a:tr>
-              <a:tr h="502920">
-                <a:tc>
-                  <a:txBody>
-                    <a:bodyPr/>
-                    <a:lstStyle/>
-                    <a:p>
-                      <a:pPr>
-                        <a:defRPr sz="1400">
-                          <a:solidFill>
-                            <a:srgbClr val="1E293B"/>
-                          </a:solidFill>
-                          <a:latin typeface="Calibri"/>
-                        </a:defRPr>
-                      </a:pPr>
-                      <a:r>
-                        <a:t>05-security</a:t>
-                      </a:r>
-                    </a:p>
-                  </a:txBody>
-                  <a:tcPr>
-                    <a:solidFill>
-                      <a:srgbClr val="F8FAFC"/>
-                    </a:solidFill>
-                  </a:tcPr>
-                </a:tc>
-                <a:tc>
-                  <a:txBody>
-                    <a:bodyPr/>
-                    <a:lstStyle/>
-                    <a:p>
-                      <a:pPr>
-                        <a:defRPr sz="1400">
-                          <a:solidFill>
-                            <a:srgbClr val="1E293B"/>
-                          </a:solidFill>
-                          <a:latin typeface="Calibri"/>
-                        </a:defRPr>
-                      </a:pPr>
-                      <a:r>
-                        <a:t>OWASP Top 10, mass assignment</a:t>
-                      </a:r>
-                    </a:p>
-                  </a:txBody>
-                  <a:tcPr>
-                    <a:solidFill>
-                      <a:srgbClr val="F8FAFC"/>
-                    </a:solidFill>
-                  </a:tcPr>
-                </a:tc>
-                <a:tc>
-                  <a:txBody>
-                    <a:bodyPr/>
-                    <a:lstStyle/>
-                    <a:p>
-                      <a:pPr>
-                        <a:defRPr sz="1400">
-                          <a:solidFill>
-                            <a:srgbClr val="1E293B"/>
-                          </a:solidFill>
-                          <a:latin typeface="Calibri"/>
-                        </a:defRPr>
-                      </a:pPr>
-                      <a:r>
-                        <a:t>15</a:t>
-                      </a:r>
-                    </a:p>
-                  </a:txBody>
-                  <a:tcPr>
-                    <a:solidFill>
-                      <a:srgbClr val="F8FAFC"/>
-                    </a:solidFill>
-                  </a:tcPr>
-                </a:tc>
-              </a:tr>
-              <a:tr h="502920">
-                <a:tc>
-                  <a:txBody>
-                    <a:bodyPr/>
-                    <a:lstStyle/>
-                    <a:p>
-                      <a:pPr>
-                        <a:defRPr sz="1400">
-                          <a:solidFill>
-                            <a:srgbClr val="1E293B"/>
-                          </a:solidFill>
-                          <a:latin typeface="Calibri"/>
-                        </a:defRPr>
-                      </a:pPr>
-                      <a:r>
-                        <a:t>06-rate-limiting</a:t>
-                      </a:r>
-                    </a:p>
-                  </a:txBody>
-                  <a:tcPr>
-                    <a:solidFill>
-                      <a:srgbClr val="FFFFFF"/>
-                    </a:solidFill>
-                  </a:tcPr>
-                </a:tc>
-                <a:tc>
-                  <a:txBody>
-                    <a:bodyPr/>
-                    <a:lstStyle/>
-                    <a:p>
-                      <a:pPr>
-                        <a:defRPr sz="1400">
-                          <a:solidFill>
-                            <a:srgbClr val="1E293B"/>
-                          </a:solidFill>
-                          <a:latin typeface="Calibri"/>
-                        </a:defRPr>
-                      </a:pPr>
-                      <a:r>
-                        <a:t>4 niveles de rate limiting</a:t>
-                      </a:r>
-                    </a:p>
-                  </a:txBody>
-                  <a:tcPr>
-                    <a:solidFill>
-                      <a:srgbClr val="FFFFFF"/>
-                    </a:solidFill>
-                  </a:tcPr>
-                </a:tc>
-                <a:tc>
-                  <a:txBody>
-                    <a:bodyPr/>
-                    <a:lstStyle/>
-                    <a:p>
-                      <a:pPr>
-                        <a:defRPr sz="1400">
-                          <a:solidFill>
-                            <a:srgbClr val="1E293B"/>
-                          </a:solidFill>
-                          <a:latin typeface="Calibri"/>
-                        </a:defRPr>
-                      </a:pPr>
-                      <a:r>
-                        <a:t>10</a:t>
-                      </a:r>
-                    </a:p>
-                  </a:txBody>
-                  <a:tcPr>
-                    <a:solidFill>
-                      <a:srgbClr val="FFFFFF"/>
-                    </a:solidFill>
-                  </a:tcPr>
-                </a:tc>
-              </a:tr>
-              <a:tr h="502920">
-                <a:tc>
-                  <a:txBody>
-                    <a:bodyPr/>
-                    <a:lstStyle/>
-                    <a:p>
-                      <a:pPr>
-                        <a:defRPr sz="1400">
-                          <a:solidFill>
-                            <a:srgbClr val="1E293B"/>
-                          </a:solidFill>
-                          <a:latin typeface="Calibri"/>
-                        </a:defRPr>
-                      </a:pPr>
-                      <a:r>
-                        <a:t>07-stripe-webhooks</a:t>
-                      </a:r>
-                    </a:p>
-                  </a:txBody>
-                  <a:tcPr>
-                    <a:solidFill>
-                      <a:srgbClr val="F8FAFC"/>
-                    </a:solidFill>
-                  </a:tcPr>
-                </a:tc>
-                <a:tc>
-                  <a:txBody>
-                    <a:bodyPr/>
-                    <a:lstStyle/>
-                    <a:p>
-                      <a:pPr>
-                        <a:defRPr sz="1400">
-                          <a:solidFill>
-                            <a:srgbClr val="1E293B"/>
-                          </a:solidFill>
-                          <a:latin typeface="Calibri"/>
-                        </a:defRPr>
-                      </a:pPr>
-                      <a:r>
-                        <a:t>Verificación firma, anti-tampering</a:t>
-                      </a:r>
-                    </a:p>
-                  </a:txBody>
-                  <a:tcPr>
-                    <a:solidFill>
-                      <a:srgbClr val="F8FAFC"/>
-                    </a:solidFill>
-                  </a:tcPr>
-                </a:tc>
-                <a:tc>
-                  <a:txBody>
-                    <a:bodyPr/>
-                    <a:lstStyle/>
-                    <a:p>
-                      <a:pPr>
-                        <a:defRPr sz="1400">
-                          <a:solidFill>
-                            <a:srgbClr val="1E293B"/>
-                          </a:solidFill>
-                          <a:latin typeface="Calibri"/>
-                        </a:defRPr>
-                      </a:pPr>
-                      <a:r>
-                        <a:t>6</a:t>
-                      </a:r>
-                    </a:p>
-                  </a:txBody>
-                  <a:tcPr>
-                    <a:solidFill>
-                      <a:srgbClr val="F8FAFC"/>
-                    </a:solidFill>
-                  </a:tcPr>
-                </a:tc>
-              </a:tr>
-              <a:tr h="502920">
-                <a:tc>
-                  <a:txBody>
-                    <a:bodyPr/>
-                    <a:lstStyle/>
-                    <a:p>
-                      <a:pPr>
-                        <a:defRPr sz="1400">
-                          <a:solidFill>
-                            <a:srgbClr val="1E293B"/>
-                          </a:solidFill>
-                          <a:latin typeface="Calibri"/>
-                        </a:defRPr>
-                      </a:pPr>
-                      <a:r>
-                        <a:t>08-rbac</a:t>
-                      </a:r>
-                    </a:p>
-                  </a:txBody>
-                  <a:tcPr>
-                    <a:solidFill>
-                      <a:srgbClr val="FFFFFF"/>
-                    </a:solidFill>
-                  </a:tcPr>
-                </a:tc>
-                <a:tc>
-                  <a:txBody>
-                    <a:bodyPr/>
-                    <a:lstStyle/>
-                    <a:p>
-                      <a:pPr>
-                        <a:defRPr sz="1400">
-                          <a:solidFill>
-                            <a:srgbClr val="1E293B"/>
-                          </a:solidFill>
-                          <a:latin typeface="Calibri"/>
-                        </a:defRPr>
-                      </a:pPr>
-                      <a:r>
-                        <a:t>Control de acceso por rol</a:t>
-                      </a:r>
-                    </a:p>
-                  </a:txBody>
-                  <a:tcPr>
-                    <a:solidFill>
-                      <a:srgbClr val="FFFFFF"/>
-                    </a:solidFill>
-                  </a:tcPr>
-                </a:tc>
-                <a:tc>
-                  <a:txBody>
-                    <a:bodyPr/>
-                    <a:lstStyle/>
-                    <a:p>
-                      <a:pPr>
-                        <a:defRPr sz="1400">
-                          <a:solidFill>
-                            <a:srgbClr val="1E293B"/>
-                          </a:solidFill>
-                          <a:latin typeface="Calibri"/>
-                        </a:defRPr>
-                      </a:pPr>
-                      <a:r>
-                        <a:t>8</a:t>
-                      </a:r>
-                    </a:p>
-                  </a:txBody>
-                  <a:tcPr>
-                    <a:solidFill>
-                      <a:srgbClr val="FFFFFF"/>
-                    </a:solidFill>
-                  </a:tcPr>
-                </a:tc>
-              </a:tr>
-              <a:tr h="502920">
-                <a:tc>
-                  <a:txBody>
-                    <a:bodyPr/>
-                    <a:lstStyle/>
-                    <a:p>
-                      <a:pPr>
-                        <a:defRPr sz="1400">
-                          <a:solidFill>
-                            <a:srgbClr val="1E293B"/>
-                          </a:solidFill>
-                          <a:latin typeface="Calibri"/>
-                        </a:defRPr>
-                      </a:pPr>
-                      <a:r>
-                        <a:t>09-lopd</a:t>
-                      </a:r>
-                    </a:p>
-                  </a:txBody>
-                  <a:tcPr>
-                    <a:solidFill>
-                      <a:srgbClr val="F8FAFC"/>
-                    </a:solidFill>
-                  </a:tcPr>
-                </a:tc>
-                <a:tc>
-                  <a:txBody>
-                    <a:bodyPr/>
-                    <a:lstStyle/>
-                    <a:p>
-                      <a:pPr>
-                        <a:defRPr sz="1400">
-                          <a:solidFill>
-                            <a:srgbClr val="1E293B"/>
-                          </a:solidFill>
-                          <a:latin typeface="Calibri"/>
-                        </a:defRPr>
-                      </a:pPr>
-                      <a:r>
-                        <a:t>Consentimiento, olvido, exportación</a:t>
-                      </a:r>
-                    </a:p>
-                  </a:txBody>
-                  <a:tcPr>
-                    <a:solidFill>
-                      <a:srgbClr val="F8FAFC"/>
-                    </a:solidFill>
-                  </a:tcPr>
-                </a:tc>
-                <a:tc>
-                  <a:txBody>
-                    <a:bodyPr/>
-                    <a:lstStyle/>
-                    <a:p>
-                      <a:pPr>
-                        <a:defRPr sz="1400">
-                          <a:solidFill>
-                            <a:srgbClr val="1E293B"/>
-                          </a:solidFill>
-                          <a:latin typeface="Calibri"/>
-                        </a:defRPr>
-                      </a:pPr>
-                      <a:r>
-                        <a:t>12</a:t>
-                      </a:r>
-                    </a:p>
-                  </a:txBody>
-                  <a:tcPr>
-                    <a:solidFill>
-                      <a:srgbClr val="F8FAFC"/>
-                    </a:solidFill>
-                  </a:tcPr>
-                </a:tc>
-              </a:tr>
-              <a:tr h="502920">
-                <a:tc>
-                  <a:txBody>
-                    <a:bodyPr/>
-                    <a:lstStyle/>
-                    <a:p>
-                      <a:pPr>
-                        <a:defRPr sz="1400">
-                          <a:solidFill>
-                            <a:srgbClr val="1E293B"/>
-                          </a:solidFill>
-                          <a:latin typeface="Calibri"/>
-                        </a:defRPr>
-                      </a:pPr>
-                      <a:r>
-                        <a:t>10-blockchain</a:t>
-                      </a:r>
-                    </a:p>
-                  </a:txBody>
-                  <a:tcPr>
-                    <a:solidFill>
-                      <a:srgbClr val="FFFFFF"/>
-                    </a:solidFill>
-                  </a:tcPr>
-                </a:tc>
-                <a:tc>
-                  <a:txBody>
-                    <a:bodyPr/>
-                    <a:lstStyle/>
-                    <a:p>
-                      <a:pPr>
-                        <a:defRPr sz="1400">
-                          <a:solidFill>
-                            <a:srgbClr val="1E293B"/>
-                          </a:solidFill>
-                          <a:latin typeface="Calibri"/>
-                        </a:defRPr>
-                      </a:pPr>
-                      <a:r>
-                        <a:t>Verificación cadena, sellado</a:t>
-                      </a:r>
-                    </a:p>
-                  </a:txBody>
-                  <a:tcPr>
-                    <a:solidFill>
-                      <a:srgbClr val="FFFFFF"/>
-                    </a:solidFill>
-                  </a:tcPr>
-                </a:tc>
-                <a:tc>
-                  <a:txBody>
-                    <a:bodyPr/>
-                    <a:lstStyle/>
-                    <a:p>
-                      <a:pPr>
-                        <a:defRPr sz="1400">
-                          <a:solidFill>
-                            <a:srgbClr val="1E293B"/>
-                          </a:solidFill>
-                          <a:latin typeface="Calibri"/>
-                        </a:defRPr>
-                      </a:pPr>
-                      <a:r>
-                        <a:t>10</a:t>
-                      </a:r>
-                    </a:p>
-                  </a:txBody>
-                  <a:tcPr>
-                    <a:solidFill>
-                      <a:srgbClr val="FFFFFF"/>
-                    </a:solidFill>
-                  </a:tcPr>
-                </a:tc>
-              </a:tr>
-              <a:tr h="502920">
-                <a:tc>
-                  <a:txBody>
-                    <a:bodyPr/>
-                    <a:lstStyle/>
-                    <a:p>
-                      <a:pPr>
-                        <a:defRPr sz="1400">
-                          <a:solidFill>
-                            <a:srgbClr val="1E293B"/>
-                          </a:solidFill>
-                          <a:latin typeface="Calibri"/>
-                        </a:defRPr>
-                      </a:pPr>
-                      <a:r>
-                        <a:t>11-new-features</a:t>
-                      </a:r>
-                    </a:p>
-                  </a:txBody>
-                  <a:tcPr>
-                    <a:solidFill>
-                      <a:srgbClr val="F8FAFC"/>
-                    </a:solidFill>
-                  </a:tcPr>
-                </a:tc>
-                <a:tc>
-                  <a:txBody>
-                    <a:bodyPr/>
-                    <a:lstStyle/>
-                    <a:p>
-                      <a:pPr>
-                        <a:defRPr sz="1400">
-                          <a:solidFill>
-                            <a:srgbClr val="1E293B"/>
-                          </a:solidFill>
-                          <a:latin typeface="Calibri"/>
-                        </a:defRPr>
-                      </a:pPr>
-                      <a:r>
-                        <a:t>Solicitudes, paginación, retiro, freeze</a:t>
-                      </a:r>
-                    </a:p>
-                  </a:txBody>
-                  <a:tcPr>
-                    <a:solidFill>
-                      <a:srgbClr val="F8FAFC"/>
-                    </a:solidFill>
-                  </a:tcPr>
-                </a:tc>
-                <a:tc>
-                  <a:txBody>
-                    <a:bodyPr/>
-                    <a:lstStyle/>
-                    <a:p>
-                      <a:pPr>
-                        <a:defRPr sz="1400">
-                          <a:solidFill>
-                            <a:srgbClr val="1E293B"/>
-                          </a:solidFill>
-                          <a:latin typeface="Calibri"/>
-                        </a:defRPr>
-                      </a:pPr>
-                      <a:r>
-                        <a:t>15</a:t>
-                      </a:r>
-                    </a:p>
-                  </a:txBody>
-                  <a:tcPr>
-                    <a:solidFill>
-                      <a:srgbClr val="F8FAFC"/>
-                    </a:solidFill>
-                  </a:tcPr>
-                </a:tc>
-              </a:tr>
-              <a:tr h="502920">
-                <a:tc>
-                  <a:txBody>
-                    <a:bodyPr/>
-                    <a:lstStyle/>
-                    <a:p>
-                      <a:pPr>
-                        <a:defRPr sz="1400">
-                          <a:solidFill>
-                            <a:srgbClr val="1E293B"/>
-                          </a:solidFill>
-                          <a:latin typeface="Calibri"/>
-                        </a:defRPr>
-                      </a:pPr>
-                      <a:r>
-                        <a:t>12-2fa</a:t>
-                      </a:r>
-                    </a:p>
-                  </a:txBody>
-                  <a:tcPr>
-                    <a:solidFill>
-                      <a:srgbClr val="FFFFFF"/>
-                    </a:solidFill>
-                  </a:tcPr>
-                </a:tc>
-                <a:tc>
-                  <a:txBody>
-                    <a:bodyPr/>
-                    <a:lstStyle/>
-                    <a:p>
-                      <a:pPr>
-                        <a:defRPr sz="1400">
-                          <a:solidFill>
-                            <a:srgbClr val="1E293B"/>
-                          </a:solidFill>
-                          <a:latin typeface="Calibri"/>
-                        </a:defRPr>
-                      </a:pPr>
-                      <a:r>
-                        <a:t>Setup TOTP, verificación, login</a:t>
-                      </a:r>
-                    </a:p>
-                  </a:txBody>
-                  <a:tcPr>
-                    <a:solidFill>
-                      <a:srgbClr val="FFFFFF"/>
-                    </a:solidFill>
-                  </a:tcPr>
-                </a:tc>
-                <a:tc>
-                  <a:txBody>
-                    <a:bodyPr/>
-                    <a:lstStyle/>
-                    <a:p>
-                      <a:pPr>
-                        <a:defRPr sz="1400">
-                          <a:solidFill>
-                            <a:srgbClr val="1E293B"/>
-                          </a:solidFill>
-                          <a:latin typeface="Calibri"/>
-                        </a:defRPr>
-                      </a:pPr>
-                      <a:r>
-                        <a:t>9</a:t>
-                      </a:r>
-                    </a:p>
-                  </a:txBody>
-                  <a:tcPr>
-                    <a:solidFill>
-                      <a:srgbClr val="FFFFFF"/>
-                    </a:solidFill>
-                  </a:tcPr>
-                </a:tc>
-              </a:tr>
-              <a:tr h="502920">
-                <a:tc>
-                  <a:txBody>
-                    <a:bodyPr/>
-                    <a:lstStyle/>
-                    <a:p>
-                      <a:pPr>
-                        <a:defRPr sz="1400">
-                          <a:solidFill>
-                            <a:srgbClr val="1E293B"/>
-                          </a:solidFill>
-                          <a:latin typeface="Calibri"/>
-                        </a:defRPr>
-                      </a:pPr>
-                      <a:r>
-                        <a:t>13-stripe-connect</a:t>
-                      </a:r>
-                    </a:p>
-                  </a:txBody>
-                  <a:tcPr>
-                    <a:solidFill>
-                      <a:srgbClr val="F8FAFC"/>
-                    </a:solidFill>
-                  </a:tcPr>
-                </a:tc>
-                <a:tc>
-                  <a:txBody>
-                    <a:bodyPr/>
-                    <a:lstStyle/>
-                    <a:p>
-                      <a:pPr>
-                        <a:defRPr sz="1400">
-                          <a:solidFill>
-                            <a:srgbClr val="1E293B"/>
-                          </a:solidFill>
-                          <a:latin typeface="Calibri"/>
-                        </a:defRPr>
-                      </a:pPr>
-                      <a:r>
-                        <a:t>Onboarding, retiro real, rollback</a:t>
-                      </a:r>
-                    </a:p>
-                  </a:txBody>
-                  <a:tcPr>
-                    <a:solidFill>
-                      <a:srgbClr val="F8FAFC"/>
-                    </a:solidFill>
-                  </a:tcPr>
-                </a:tc>
-                <a:tc>
-                  <a:txBody>
-                    <a:bodyPr/>
-                    <a:lstStyle/>
-                    <a:p>
-                      <a:pPr>
-                        <a:defRPr sz="1400">
-                          <a:solidFill>
-                            <a:srgbClr val="1E293B"/>
-                          </a:solidFill>
-                          <a:latin typeface="Calibri"/>
-                        </a:defRPr>
-                      </a:pPr>
-                      <a:r>
-                        <a:t>15</a:t>
-                      </a:r>
-                    </a:p>
-                  </a:txBody>
-                  <a:tcPr>
-                    <a:solidFill>
-                      <a:srgbClr val="F8FAFC"/>
                     </a:solidFill>
                   </a:tcPr>
                 </a:tc>
@@ -10961,8 +10591,8 @@
         </p:nvSpPr>
         <p:spPr>
           <a:xfrm>
-            <a:off x="457200" y="2926080"/>
-            <a:ext cx="1645920" cy="914400"/>
+            <a:off x="457200" y="2743200"/>
+            <a:ext cx="1463040" cy="914400"/>
           </a:xfrm>
           <a:prstGeom prst="rect">
             <a:avLst/>
@@ -11014,7 +10644,7 @@
         </p:nvSpPr>
         <p:spPr>
           <a:xfrm>
-            <a:off x="2743200" y="2926080"/>
+            <a:off x="2286000" y="2743200"/>
             <a:ext cx="2011680" cy="914400"/>
           </a:xfrm>
           <a:prstGeom prst="rect">
@@ -11058,7 +10688,7 @@
             </a:r>
             <a:br/>
             <a:r>
-              <a:t>CDN + HTTPS + WAF</a:t>
+              <a:t>CDN · HTTPS · WAF</a:t>
             </a:r>
           </a:p>
         </p:txBody>
@@ -11071,7 +10701,7 @@
         </p:nvSpPr>
         <p:spPr>
           <a:xfrm>
-            <a:off x="5486400" y="2926080"/>
+            <a:off x="4663440" y="2743200"/>
             <a:ext cx="2011680" cy="914400"/>
           </a:xfrm>
           <a:prstGeom prst="rect">
@@ -11128,8 +10758,8 @@
         </p:nvSpPr>
         <p:spPr>
           <a:xfrm>
-            <a:off x="8229600" y="1828800"/>
-            <a:ext cx="2011680" cy="914400"/>
+            <a:off x="7040880" y="1645920"/>
+            <a:ext cx="2194560" cy="914400"/>
           </a:xfrm>
           <a:prstGeom prst="rect">
             <a:avLst/>
@@ -11185,8 +10815,8 @@
         </p:nvSpPr>
         <p:spPr>
           <a:xfrm>
-            <a:off x="8229600" y="4023360"/>
-            <a:ext cx="2011680" cy="914400"/>
+            <a:off x="7040880" y="3840480"/>
+            <a:ext cx="2194560" cy="914400"/>
           </a:xfrm>
           <a:prstGeom prst="rect">
             <a:avLst/>
@@ -11242,8 +10872,8 @@
         </p:nvSpPr>
         <p:spPr>
           <a:xfrm>
-            <a:off x="10972800" y="3383280"/>
-            <a:ext cx="1828800" cy="914400"/>
+            <a:off x="9601200" y="2743200"/>
+            <a:ext cx="2286000" cy="914400"/>
           </a:xfrm>
           <a:prstGeom prst="rect">
             <a:avLst/>
@@ -11299,8 +10929,8 @@
         </p:nvSpPr>
         <p:spPr>
           <a:xfrm>
-            <a:off x="10972800" y="4754880"/>
-            <a:ext cx="1828800" cy="914400"/>
+            <a:off x="9601200" y="4114800"/>
+            <a:ext cx="2286000" cy="914400"/>
           </a:xfrm>
           <a:prstGeom prst="rect">
             <a:avLst/>
@@ -11348,16 +10978,226 @@
           </a:p>
         </p:txBody>
       </p:sp>
-      <p:sp>
-        <p:nvSpPr>
-          <p:cNvPr id="12" name="TextBox 11"/>
+      <p:cxnSp>
+        <p:nvCxnSpPr>
+          <p:cNvPr id="12" name="Connector 11"/>
+          <p:cNvCxnSpPr/>
+          <p:nvPr/>
+        </p:nvCxnSpPr>
+        <p:spPr>
+          <a:xfrm>
+            <a:off x="1920240" y="3200400"/>
+            <a:ext cx="365760" cy="0"/>
+          </a:xfrm>
+          <a:prstGeom prst="line">
+            <a:avLst/>
+          </a:prstGeom>
+          <a:ln w="25400">
+            <a:solidFill>
+              <a:srgbClr val="1E293B"/>
+            </a:solidFill>
+          </a:ln>
+        </p:spPr>
+        <p:style>
+          <a:lnRef idx="2">
+            <a:schemeClr val="accent1"/>
+          </a:lnRef>
+          <a:fillRef idx="0">
+            <a:schemeClr val="accent1"/>
+          </a:fillRef>
+          <a:effectRef idx="1">
+            <a:schemeClr val="accent1"/>
+          </a:effectRef>
+          <a:fontRef idx="minor">
+            <a:schemeClr val="tx1"/>
+          </a:fontRef>
+        </p:style>
+      </p:cxnSp>
+      <p:cxnSp>
+        <p:nvCxnSpPr>
+          <p:cNvPr id="13" name="Connector 12"/>
+          <p:cNvCxnSpPr/>
+          <p:nvPr/>
+        </p:nvCxnSpPr>
+        <p:spPr>
+          <a:xfrm>
+            <a:off x="4297680" y="3200400"/>
+            <a:ext cx="365760" cy="0"/>
+          </a:xfrm>
+          <a:prstGeom prst="line">
+            <a:avLst/>
+          </a:prstGeom>
+          <a:ln w="25400">
+            <a:solidFill>
+              <a:srgbClr val="1E293B"/>
+            </a:solidFill>
+          </a:ln>
+        </p:spPr>
+        <p:style>
+          <a:lnRef idx="2">
+            <a:schemeClr val="accent1"/>
+          </a:lnRef>
+          <a:fillRef idx="0">
+            <a:schemeClr val="accent1"/>
+          </a:fillRef>
+          <a:effectRef idx="1">
+            <a:schemeClr val="accent1"/>
+          </a:effectRef>
+          <a:fontRef idx="minor">
+            <a:schemeClr val="tx1"/>
+          </a:fontRef>
+        </p:style>
+      </p:cxnSp>
+      <p:cxnSp>
+        <p:nvCxnSpPr>
+          <p:cNvPr id="14" name="Connector 13"/>
+          <p:cNvCxnSpPr/>
+          <p:nvPr/>
+        </p:nvCxnSpPr>
+        <p:spPr>
+          <a:xfrm flipV="1">
+            <a:off x="6675120" y="2103120"/>
+            <a:ext cx="365760" cy="914400"/>
+          </a:xfrm>
+          <a:prstGeom prst="line">
+            <a:avLst/>
+          </a:prstGeom>
+          <a:ln w="25400">
+            <a:solidFill>
+              <a:srgbClr val="1E293B"/>
+            </a:solidFill>
+          </a:ln>
+        </p:spPr>
+        <p:style>
+          <a:lnRef idx="2">
+            <a:schemeClr val="accent1"/>
+          </a:lnRef>
+          <a:fillRef idx="0">
+            <a:schemeClr val="accent1"/>
+          </a:fillRef>
+          <a:effectRef idx="1">
+            <a:schemeClr val="accent1"/>
+          </a:effectRef>
+          <a:fontRef idx="minor">
+            <a:schemeClr val="tx1"/>
+          </a:fontRef>
+        </p:style>
+      </p:cxnSp>
+      <p:cxnSp>
+        <p:nvCxnSpPr>
+          <p:cNvPr id="15" name="Connector 14"/>
+          <p:cNvCxnSpPr/>
+          <p:nvPr/>
+        </p:nvCxnSpPr>
+        <p:spPr>
+          <a:xfrm>
+            <a:off x="6675120" y="3383280"/>
+            <a:ext cx="365760" cy="914400"/>
+          </a:xfrm>
+          <a:prstGeom prst="line">
+            <a:avLst/>
+          </a:prstGeom>
+          <a:ln w="25400">
+            <a:solidFill>
+              <a:srgbClr val="1E293B"/>
+            </a:solidFill>
+          </a:ln>
+        </p:spPr>
+        <p:style>
+          <a:lnRef idx="2">
+            <a:schemeClr val="accent1"/>
+          </a:lnRef>
+          <a:fillRef idx="0">
+            <a:schemeClr val="accent1"/>
+          </a:fillRef>
+          <a:effectRef idx="1">
+            <a:schemeClr val="accent1"/>
+          </a:effectRef>
+          <a:fontRef idx="minor">
+            <a:schemeClr val="tx1"/>
+          </a:fontRef>
+        </p:style>
+      </p:cxnSp>
+      <p:cxnSp>
+        <p:nvCxnSpPr>
+          <p:cNvPr id="16" name="Connector 15"/>
+          <p:cNvCxnSpPr/>
+          <p:nvPr/>
+        </p:nvCxnSpPr>
+        <p:spPr>
+          <a:xfrm flipV="1">
+            <a:off x="9235440" y="3200400"/>
+            <a:ext cx="365760" cy="822960"/>
+          </a:xfrm>
+          <a:prstGeom prst="line">
+            <a:avLst/>
+          </a:prstGeom>
+          <a:ln w="25400">
+            <a:solidFill>
+              <a:srgbClr val="1E293B"/>
+            </a:solidFill>
+          </a:ln>
+        </p:spPr>
+        <p:style>
+          <a:lnRef idx="2">
+            <a:schemeClr val="accent1"/>
+          </a:lnRef>
+          <a:fillRef idx="0">
+            <a:schemeClr val="accent1"/>
+          </a:fillRef>
+          <a:effectRef idx="1">
+            <a:schemeClr val="accent1"/>
+          </a:effectRef>
+          <a:fontRef idx="minor">
+            <a:schemeClr val="tx1"/>
+          </a:fontRef>
+        </p:style>
+      </p:cxnSp>
+      <p:cxnSp>
+        <p:nvCxnSpPr>
+          <p:cNvPr id="17" name="Connector 16"/>
+          <p:cNvCxnSpPr/>
+          <p:nvPr/>
+        </p:nvCxnSpPr>
+        <p:spPr>
+          <a:xfrm>
+            <a:off x="9235440" y="4389120"/>
+            <a:ext cx="365760" cy="182880"/>
+          </a:xfrm>
+          <a:prstGeom prst="line">
+            <a:avLst/>
+          </a:prstGeom>
+          <a:ln w="25400">
+            <a:solidFill>
+              <a:srgbClr val="1E293B"/>
+            </a:solidFill>
+          </a:ln>
+        </p:spPr>
+        <p:style>
+          <a:lnRef idx="2">
+            <a:schemeClr val="accent1"/>
+          </a:lnRef>
+          <a:fillRef idx="0">
+            <a:schemeClr val="accent1"/>
+          </a:fillRef>
+          <a:effectRef idx="1">
+            <a:schemeClr val="accent1"/>
+          </a:effectRef>
+          <a:fontRef idx="minor">
+            <a:schemeClr val="tx1"/>
+          </a:fontRef>
+        </p:style>
+      </p:cxnSp>
+      <p:sp>
+        <p:nvSpPr>
+          <p:cNvPr id="18" name="TextBox 17"/>
           <p:cNvSpPr txBox="1"/>
           <p:nvPr/>
         </p:nvSpPr>
         <p:spPr>
           <a:xfrm>
             <a:off x="731520" y="5669280"/>
-            <a:ext cx="10058400" cy="457200"/>
+            <a:ext cx="10515600" cy="457200"/>
           </a:xfrm>
           <a:prstGeom prst="rect">
             <a:avLst/>
@@ -11370,7 +11210,7 @@
           </a:bodyPr>
           <a:lstStyle/>
           <a:p>
-            <a:pPr algn="l">
+            <a:pPr algn="ctr">
               <a:defRPr sz="1400" b="0">
                 <a:solidFill>
                   <a:srgbClr val="64748B"/>
@@ -11379,7 +11219,7 @@
               </a:defRPr>
             </a:pPr>
             <a:r>
-              <a:t>Internet  →  Cloudflare  →  Nginx  →  Frontend / Backend  →  MongoDB Atlas + RabbitMQ</a:t>
+              <a:t>Internet  →  Cloudflare  →  Nginx  →  {Frontend · Backend}  →  MongoDB Atlas + RabbitMQ</a:t>
             </a:r>
           </a:p>
         </p:txBody>

</xml_diff>